<commit_message>
Atualiza a apresentacao com capturas do site em producao, link publico e QR Code
</commit_message>
<xml_diff>
--- a/apresentacao/Apresentacao-Area-Comum-Sao-Cristovao.pptx
+++ b/apresentacao/Apresentacao-Area-Comum-Sao-Cristovao.pptx
@@ -723,7 +723,7 @@
           <a:lstStyle/>
           <a:p>
             <a:r>
-              <a:t>Encerramento com o caminho de implantação e os acessos de demonstração. A aprovação pode acontecer em assembleia e o piloto valida a operação antes do lançamento.</a:t>
+              <a:t>Encerramento com o caminho de implantação e os acessos de demonstração. O sistema já está publicado: area-comum.onrender.com (link público e gratuito, com HTTPS). Mostre o QR Code para a assembleia abrir no celular na hora, ou use as contas de teste ao lado. A aprovação pode acontecer em assembleia e o piloto valida a operação antes do lançamento.</a:t>
             </a:r>
           </a:p>
         </p:txBody>
@@ -9012,7 +9012,7 @@
         </p:nvSpPr>
         <p:spPr>
           <a:xfrm>
-            <a:off x="868680" y="4005072"/>
+            <a:off x="868680" y="3986784"/>
             <a:ext cx="5486400" cy="228600"/>
           </a:xfrm>
           <a:prstGeom prst="rect">
@@ -9041,7 +9041,7 @@
                 </a:solidFill>
                 <a:latin typeface="Segoe UI"/>
               </a:rPr>
-              <a:t>ACESSE A DEMONSTRAÇÃO</a:t>
+              <a:t>SISTEMA NO AR — ACESSE AGORA</a:t>
             </a:r>
           </a:p>
         </p:txBody>
@@ -9054,8 +9054,8 @@
         </p:nvSpPr>
         <p:spPr>
           <a:xfrm>
-            <a:off x="868680" y="4297680"/>
-            <a:ext cx="5577840" cy="731520"/>
+            <a:off x="868680" y="4233672"/>
+            <a:ext cx="3474720" cy="658368"/>
           </a:xfrm>
           <a:prstGeom prst="rect">
             <a:avLst/>
@@ -9077,13 +9077,13 @@
               </a:spcAft>
             </a:pPr>
             <a:r>
-              <a:rPr sz="1700" b="1" i="0">
+              <a:rPr sz="1450" b="1" i="0">
                 <a:solidFill>
                   <a:srgbClr val="122F27"/>
                 </a:solidFill>
                 <a:latin typeface="Segoe UI"/>
               </a:rPr>
-              <a:t>http://127.0.0.1:3000</a:t>
+              <a:t>area-comum.onrender.com</a:t>
             </a:r>
           </a:p>
           <a:p>
@@ -9102,7 +9102,7 @@
                 </a:solidFill>
                 <a:latin typeface="Segoe UI"/>
               </a:rPr>
-              <a:t>Na rede local: http://192.168.15.166:3000</a:t>
+              <a:t>Link público, gratuito e com HTTPS.</a:t>
             </a:r>
           </a:p>
         </p:txBody>
@@ -9115,8 +9115,8 @@
         </p:nvSpPr>
         <p:spPr>
           <a:xfrm>
-            <a:off x="868680" y="5102352"/>
-            <a:ext cx="5577840" cy="502920"/>
+            <a:off x="868680" y="4846320"/>
+            <a:ext cx="3520440" cy="777240"/>
           </a:xfrm>
           <a:prstGeom prst="rect">
             <a:avLst/>
@@ -9138,20 +9138,128 @@
               </a:spcAft>
             </a:pPr>
             <a:r>
-              <a:rPr sz="750" b="0" i="0">
+              <a:rPr sz="730" b="0" i="0">
                 <a:solidFill>
                   <a:srgbClr val="64746E"/>
                 </a:solidFill>
                 <a:latin typeface="Segoe UI"/>
               </a:rPr>
-              <a:t>Abra no navegador deste computador. Para o cliente acessar de outro dispositivo, use o endereço da rede local ou configure um túnel/hospedagem.</a:t>
-            </a:r>
-          </a:p>
-        </p:txBody>
-      </p:sp>
-      <p:sp>
-        <p:nvSpPr>
-          <p:cNvPr id="25" name="Rectangle 24"/>
+              <a:t>Abra em qualquer computador ou celular, sem instalar nada nem usar a rede do condomínio. Na primeira visita após um período sem uso, o servidor gratuito pode levar até 1 minuto para responder.</a:t>
+            </a:r>
+          </a:p>
+        </p:txBody>
+      </p:sp>
+      <p:sp>
+        <p:nvSpPr>
+          <p:cNvPr id="25" name="TextBox 24"/>
+          <p:cNvSpPr txBox="1"/>
+          <p:nvPr/>
+        </p:nvSpPr>
+        <p:spPr>
+          <a:xfrm>
+            <a:off x="868680" y="5559552"/>
+            <a:ext cx="3520440" cy="219456"/>
+          </a:xfrm>
+          <a:prstGeom prst="rect">
+            <a:avLst/>
+          </a:prstGeom>
+          <a:noFill/>
+        </p:spPr>
+        <p:txBody>
+          <a:bodyPr wrap="square" anchor="t" lIns="0" rIns="0" tIns="0" bIns="0">
+            <a:spAutoFit/>
+          </a:bodyPr>
+          <a:lstStyle/>
+          <a:p>
+            <a:pPr algn="l">
+              <a:lnSpc>
+                <a:spcPct val="105000"/>
+              </a:lnSpc>
+              <a:spcAft>
+                <a:spcPts val="500"/>
+              </a:spcAft>
+            </a:pPr>
+            <a:r>
+              <a:rPr sz="660" b="0" i="0">
+                <a:solidFill>
+                  <a:srgbClr val="64746E"/>
+                </a:solidFill>
+                <a:latin typeface="Segoe UI"/>
+              </a:rPr>
+              <a:t>Demonstração local: http://127.0.0.1:3000 (neste computador)</a:t>
+            </a:r>
+          </a:p>
+        </p:txBody>
+      </p:sp>
+      <p:pic>
+        <p:nvPicPr>
+          <p:cNvPr id="26" name="Picture 25" descr="qr-acesso.png"/>
+          <p:cNvPicPr>
+            <a:picLocks noChangeAspect="1"/>
+          </p:cNvPicPr>
+          <p:nvPr/>
+        </p:nvPicPr>
+        <p:blipFill>
+          <a:blip r:embed="rId3"/>
+          <a:stretch>
+            <a:fillRect/>
+          </a:stretch>
+        </p:blipFill>
+        <p:spPr>
+          <a:xfrm>
+            <a:off x="4590288" y="4206240"/>
+            <a:ext cx="1280160" cy="1280160"/>
+          </a:xfrm>
+          <a:prstGeom prst="rect">
+            <a:avLst/>
+          </a:prstGeom>
+        </p:spPr>
+      </p:pic>
+      <p:sp>
+        <p:nvSpPr>
+          <p:cNvPr id="27" name="TextBox 26"/>
+          <p:cNvSpPr txBox="1"/>
+          <p:nvPr/>
+        </p:nvSpPr>
+        <p:spPr>
+          <a:xfrm>
+            <a:off x="4590288" y="5541264"/>
+            <a:ext cx="1280160" cy="219456"/>
+          </a:xfrm>
+          <a:prstGeom prst="rect">
+            <a:avLst/>
+          </a:prstGeom>
+          <a:noFill/>
+        </p:spPr>
+        <p:txBody>
+          <a:bodyPr wrap="square" anchor="t" lIns="0" rIns="0" tIns="0" bIns="0">
+            <a:spAutoFit/>
+          </a:bodyPr>
+          <a:lstStyle/>
+          <a:p>
+            <a:pPr algn="ctr">
+              <a:lnSpc>
+                <a:spcPct val="105000"/>
+              </a:lnSpc>
+              <a:spcAft>
+                <a:spcPts val="500"/>
+              </a:spcAft>
+            </a:pPr>
+            <a:r>
+              <a:rPr sz="650" b="1" i="0">
+                <a:solidFill>
+                  <a:srgbClr val="8A5F1E"/>
+                </a:solidFill>
+                <a:latin typeface="Segoe UI"/>
+              </a:rPr>
+              <a:t>Aponte a câmera</a:t>
+            </a:r>
+          </a:p>
+        </p:txBody>
+      </p:sp>
+      <p:sp>
+        <p:nvSpPr>
+          <p:cNvPr id="28" name="Rectangle 27"/>
           <p:cNvSpPr/>
           <p:nvPr/>
         </p:nvSpPr>
@@ -9194,7 +9302,7 @@
       </p:sp>
       <p:sp>
         <p:nvSpPr>
-          <p:cNvPr id="26" name="TextBox 25"/>
+          <p:cNvPr id="29" name="TextBox 28"/>
           <p:cNvSpPr txBox="1"/>
           <p:nvPr/>
         </p:nvSpPr>
@@ -9236,7 +9344,7 @@
       </p:sp>
       <p:sp>
         <p:nvSpPr>
-          <p:cNvPr id="27" name="TextBox 26"/>
+          <p:cNvPr id="30" name="TextBox 29"/>
           <p:cNvSpPr txBox="1"/>
           <p:nvPr/>
         </p:nvSpPr>
@@ -9278,7 +9386,7 @@
       </p:sp>
       <p:sp>
         <p:nvSpPr>
-          <p:cNvPr id="28" name="TextBox 27"/>
+          <p:cNvPr id="31" name="TextBox 30"/>
           <p:cNvSpPr txBox="1"/>
           <p:nvPr/>
         </p:nvSpPr>
@@ -9320,7 +9428,7 @@
       </p:sp>
       <p:sp>
         <p:nvSpPr>
-          <p:cNvPr id="29" name="TextBox 28"/>
+          <p:cNvPr id="32" name="TextBox 31"/>
           <p:cNvSpPr txBox="1"/>
           <p:nvPr/>
         </p:nvSpPr>
@@ -9362,7 +9470,7 @@
       </p:sp>
       <p:sp>
         <p:nvSpPr>
-          <p:cNvPr id="30" name="TextBox 29"/>
+          <p:cNvPr id="33" name="TextBox 32"/>
           <p:cNvSpPr txBox="1"/>
           <p:nvPr/>
         </p:nvSpPr>
@@ -9404,7 +9512,7 @@
       </p:sp>
       <p:sp>
         <p:nvSpPr>
-          <p:cNvPr id="31" name="TextBox 30"/>
+          <p:cNvPr id="34" name="TextBox 33"/>
           <p:cNvSpPr txBox="1"/>
           <p:nvPr/>
         </p:nvSpPr>
@@ -9446,7 +9554,7 @@
       </p:sp>
       <p:sp>
         <p:nvSpPr>
-          <p:cNvPr id="32" name="TextBox 31"/>
+          <p:cNvPr id="35" name="TextBox 34"/>
           <p:cNvSpPr txBox="1"/>
           <p:nvPr/>
         </p:nvSpPr>
@@ -9488,7 +9596,7 @@
       </p:sp>
       <p:sp>
         <p:nvSpPr>
-          <p:cNvPr id="33" name="TextBox 32"/>
+          <p:cNvPr id="36" name="TextBox 35"/>
           <p:cNvSpPr txBox="1"/>
           <p:nvPr/>
         </p:nvSpPr>
@@ -9523,14 +9631,14 @@
                 </a:solidFill>
                 <a:latin typeface="Segoe UI"/>
               </a:rPr>
-              <a:t>Documentação, testes e capturas de tela estão inclusos no projeto.</a:t>
-            </a:r>
-          </a:p>
-        </p:txBody>
-      </p:sp>
-      <p:sp>
-        <p:nvSpPr>
-          <p:cNvPr id="34" name="TextBox 33"/>
+              <a:t>Sistema publicado, com testes automatizados de regras e capturas do site em produção.</a:t>
+            </a:r>
+          </a:p>
+        </p:txBody>
+      </p:sp>
+      <p:sp>
+        <p:nvSpPr>
+          <p:cNvPr id="37" name="TextBox 36"/>
           <p:cNvSpPr txBox="1"/>
           <p:nvPr/>
         </p:nvSpPr>

</xml_diff>